<commit_message>
docs: strip competition and author identifiers; regenerate deck and poster
</commit_message>
<xml_diff>
--- a/report/slides/低延迟视觉增强终端_5分钟汇报.pptx
+++ b/report/slides/低延迟视觉增强终端_5分钟汇报.pptx
@@ -4324,7 +4324,7 @@
                 <a:latin typeface="Microsoft YaHei"/>
                 <a:ea typeface="Microsoft YaHei"/>
               </a:rPr>
-              <a:t>2026 全国大学生嵌入式芯片与系统设计竞赛  ·  FPGA 创新设计赛道  ·  AMD 自主选题（初级组）</a:t>
+              <a:t>技术方案与板级验证  ·  PYNQ-Z2（Zynq-7020）  ·  Vivado / Vitis HLS 2026.1</a:t>
             </a:r>
           </a:p>
         </p:txBody>
@@ -5452,7 +5452,7 @@
                 <a:latin typeface="Microsoft YaHei"/>
                 <a:ea typeface="Microsoft YaHei"/>
               </a:rPr>
-              <a:t>低延迟视觉增强终端  ·  PYNQ-Z2  ·  2026 嵌入式芯片与系统设计竞赛</a:t>
+              <a:t>低延迟视觉增强终端  ·  PYNQ-Z2  ·  Zynq-7020</a:t>
             </a:r>
           </a:p>
         </p:txBody>
@@ -6734,7 +6734,7 @@
                 <a:latin typeface="Microsoft YaHei"/>
                 <a:ea typeface="Microsoft YaHei"/>
               </a:rPr>
-              <a:t>低延迟视觉增强终端  ·  PYNQ-Z2  ·  2026 嵌入式芯片与系统设计竞赛</a:t>
+              <a:t>低延迟视觉增强终端  ·  PYNQ-Z2  ·  Zynq-7020</a:t>
             </a:r>
           </a:p>
         </p:txBody>
@@ -8054,7 +8054,7 @@
                 <a:latin typeface="Microsoft YaHei"/>
                 <a:ea typeface="Microsoft YaHei"/>
               </a:rPr>
-              <a:t>低延迟视觉增强终端  ·  PYNQ-Z2  ·  2026 嵌入式芯片与系统设计竞赛</a:t>
+              <a:t>低延迟视觉增强终端  ·  PYNQ-Z2  ·  Zynq-7020</a:t>
             </a:r>
           </a:p>
         </p:txBody>
@@ -8528,7 +8528,7 @@
                 <a:latin typeface="Microsoft YaHei"/>
                 <a:ea typeface="Microsoft YaHei"/>
               </a:rPr>
-              <a:t>低延迟视觉增强终端  ·  PYNQ-Z2  ·  2026 嵌入式芯片与系统设计竞赛</a:t>
+              <a:t>低延迟视觉增强终端  ·  PYNQ-Z2  ·  Zynq-7020</a:t>
             </a:r>
           </a:p>
         </p:txBody>
@@ -9264,7 +9264,7 @@
                 <a:latin typeface="Microsoft YaHei"/>
                 <a:ea typeface="Microsoft YaHei"/>
               </a:rPr>
-              <a:t>低延迟视觉增强终端  ·  PYNQ-Z2  ·  2026 嵌入式芯片与系统设计竞赛</a:t>
+              <a:t>低延迟视觉增强终端  ·  PYNQ-Z2  ·  Zynq-7020</a:t>
             </a:r>
           </a:p>
         </p:txBody>
@@ -10248,7 +10248,7 @@
                 <a:latin typeface="Microsoft YaHei"/>
                 <a:ea typeface="Microsoft YaHei"/>
               </a:rPr>
-              <a:t>低延迟视觉增强终端  ·  PYNQ-Z2  ·  2026 嵌入式芯片与系统设计竞赛</a:t>
+              <a:t>低延迟视觉增强终端  ·  PYNQ-Z2  ·  Zynq-7020</a:t>
             </a:r>
           </a:p>
         </p:txBody>
@@ -11248,7 +11248,7 @@
                 <a:latin typeface="Microsoft YaHei"/>
                 <a:ea typeface="Microsoft YaHei"/>
               </a:rPr>
-              <a:t>低延迟视觉增强终端  ·  PYNQ-Z2  ·  2026 嵌入式芯片与系统设计竞赛</a:t>
+              <a:t>低延迟视觉增强终端  ·  PYNQ-Z2  ·  Zynq-7020</a:t>
             </a:r>
           </a:p>
         </p:txBody>
@@ -12134,7 +12134,7 @@
                 <a:latin typeface="Microsoft YaHei"/>
                 <a:ea typeface="Microsoft YaHei"/>
               </a:rPr>
-              <a:t>低延迟视觉增强终端  ·  PYNQ-Z2  ·  2026 嵌入式芯片与系统设计竞赛</a:t>
+              <a:t>低延迟视觉增强终端  ·  PYNQ-Z2  ·  Zynq-7020</a:t>
             </a:r>
           </a:p>
         </p:txBody>

</xml_diff>